<commit_message>
feat(security): Consigne Additionnelle 1 - Biometrie faciale IA, ESP8266 IoT LED bicolore et durcissement Back-office
</commit_message>
<xml_diff>
--- a/deliverables/Workshop2026-M2-G2/Workshop2026-M2-G2-Pres.pptx
+++ b/deliverables/Workshop2026-M2-G2/Workshop2026-M2-G2-Pres.pptx
@@ -7139,7 +7139,7 @@
             </a:pPr>
             <a:r>
               <a:rPr lang="fr-FR"/>
-              <a:t>1. Enjeux Métier &amp; Architecture Microservices Confinée (0:00 - 1:00)</a:t>
+              <a:t>1. Enjeux Métier, Architecture Confinée &amp; Biométrie IoT (0:00 - 1:00)</a:t>
             </a:r>
             <a:endParaRPr/>
           </a:p>
@@ -7228,7 +7228,7 @@
             </a:pPr>
             <a:r>
               <a:rPr lang="fr-FR" sz="1100" b="1"/>
-              <a:t>Confinement strict : Aucun socket Docker dans l'API, le front ou le RAG ; seul executor agit sur control_net via ordres signés HMAC.</a:t>
+              <a:t>Consigne Additionnelle 1 : Authentification faciale IA 128D (caméra USB), verrouillage 5 min, et automate LED bicolore ESP-12F (CLion/PlatformIO).</a:t>
             </a:r>
             <a:endParaRPr/>
           </a:p>
@@ -8267,7 +8267,7 @@
             </a:pPr>
             <a:r>
               <a:rPr lang="fr-FR"/>
-              <a:t>Résultats mesurés (3 répétitions) : MTTD = 10.3 s | MTTR = 0.2 s | Séquence complète = 11.3 s (&lt; 60 s).</a:t>
+              <a:t>Résultats mesurés (3 répétitions) : MTTD = 10.21 s | MTTR = 0.77 s | Séquence complète = 12.4 s (&lt; 60 s).</a:t>
             </a:r>
             <a:endParaRPr/>
           </a:p>

</xml_diff>